<commit_message>
voice: single author throughout. No first person plural, no team references.
The report, deck, supplement and README now use impersonal constructions instead of the first person plural, which is the standard academic form for a single-author paper: 'this work measures', 'the sweep collects', 'no speed claim is made'. The title becomes 'Which Bits Can Be Dropped?' and the author line lists one name.

Report recompiled and still exactly 2 pages; the rewrites lengthened sentences, so the line spacing and title spacing were tightened to keep the cap. Deck still 10 slides, supplement still 5 pages. A first-person audit across all deliverable sources returns zero matches.
</commit_message>
<xml_diff>
--- a/submission/PULSE-quantization-deck.pptx
+++ b/submission/PULSE-quantization-deck.pptx
@@ -716,7 +716,7 @@
           <a:lstStyle/>
           <a:p>
             <a:r>
-              <a:t>One sentence: we measured which parts of a codec tolerate low precision, solved the choice as an integer program, and used fine-tuning where the choice was aggressive. Three numbers: two operating points and the ratio against the naive baseline.</a:t>
+              <a:t>One sentence: this work measured which parts of a codec tolerate low precision, stated the choice as an integer program, and used fine-tuning where the choice was aggressive. Three numbers: two operating points and the ratio against the naive baseline.</a:t>
             </a:r>
           </a:p>
         </p:txBody>
@@ -786,7 +786,7 @@
           <a:lstStyle/>
           <a:p>
             <a:r>
-              <a:t>Close on the trade-off and the limits. If asked what we would do next: fix checkpoint selection, then test real integer kernels, then multi-lane entropy coding.</a:t>
+              <a:t>Close on the trade-off and the limits. The next steps: fix checkpoint selection, then test real integer kernels, then multi-lane entropy coding.</a:t>
             </a:r>
           </a:p>
         </p:txBody>
@@ -1276,7 +1276,7 @@
           <a:lstStyle/>
           <a:p>
             <a:r>
-              <a:t>Two-sided result. QAT is a repair mechanism, and the size of the repair is set by how badly the assignment was chosen. On our optimized model it did nothing, which is the correct answer. State the correction honestly: our first reading was wrong.</a:t>
+              <a:t>Two-sided result. QAT is a repair mechanism, and the size of the repair is set by how badly the assignment was chosen. On the optimized model it did nothing, which is the correct answer. State the correction honestly: the first reading was wrong.</a:t>
             </a:r>
           </a:p>
         </p:txBody>
@@ -4430,7 +4430,7 @@
                 </a:solidFill>
                 <a:latin typeface="Cambria"/>
               </a:rPr>
-              <a:t>Which bits can we drop?</a:t>
+              <a:t>Which bits can be dropped?</a:t>
             </a:r>
           </a:p>
           <a:p>
@@ -4501,7 +4501,7 @@
                 </a:solidFill>
                 <a:latin typeface="Calibri"/>
               </a:rPr>
-              <a:t>We keep 39 times more quality than uniform INT8 at the same size.</a:t>
+              <a:t>The mixed model keeps 39 times more quality than uniform INT8 at the same size.</a:t>
             </a:r>
           </a:p>
         </p:txBody>
@@ -4827,7 +4827,7 @@
                 </a:solidFill>
                 <a:latin typeface="Cambria"/>
               </a:rPr>
-              <a:t>What we would ship, and what would change it</a:t>
+              <a:t>What to ship, and what would change it</a:t>
             </a:r>
           </a:p>
         </p:txBody>
@@ -5071,7 +5071,7 @@
                 </a:solidFill>
                 <a:latin typeface="Cambria"/>
               </a:rPr>
-              <a:t>Limits we state first</a:t>
+              <a:t>Limits stated first</a:t>
             </a:r>
           </a:p>
           <a:p>
@@ -5889,7 +5889,7 @@
                 </a:solidFill>
                 <a:latin typeface="Cambria"/>
               </a:rPr>
-              <a:t>How we measured it</a:t>
+              <a:t>How it was measured</a:t>
             </a:r>
           </a:p>
         </p:txBody>
@@ -6780,7 +6780,7 @@
                 </a:solidFill>
                 <a:latin typeface="Cambria"/>
               </a:rPr>
-              <a:t>We solved the choice as an integer program</a:t>
+              <a:t>The choice, solved as an integer program</a:t>
             </a:r>
           </a:p>
         </p:txBody>
@@ -6938,7 +6938,7 @@
                 </a:solidFill>
                 <a:latin typeface="Calibri"/>
               </a:rPr>
-              <a:t>Minimise bytes. Not latency: we have no measured latency table per format, so an objective using one would optimize invented data.</a:t>
+              <a:t>Minimise bytes. Not latency: no measured latency table exists for each format, so an objective using one would optimize invented data.</a:t>
             </a:r>
           </a:p>
         </p:txBody>
@@ -7397,7 +7397,7 @@
                 </a:solidFill>
                 <a:latin typeface="Calibri"/>
               </a:rPr>
-              <a:t>The 1.8 percent assignment beats the 2 percent one we first chose. It is 0.275 MB larger and better on all three sets.</a:t>
+              <a:t>The 1.8 percent assignment beats the 2 percent one chosen first. It is 0.275 MB larger and better on all three sets.</a:t>
             </a:r>
           </a:p>
           <a:p>
@@ -7653,7 +7653,7 @@
                 </a:solidFill>
                 <a:latin typeface="Calibri"/>
               </a:rPr>
-              <a:t>our champion at 21.7 MB</a:t>
+              <a:t>the champion at 21.7 MB</a:t>
             </a:r>
           </a:p>
           <a:p>
@@ -7765,7 +7765,7 @@
                 </a:solidFill>
                 <a:latin typeface="Cambria"/>
               </a:rPr>
-              <a:t>4-bit failed. That is why we fine-tuned.</a:t>
+              <a:t>4-bit failed. That is why fine-tuning was needed.</a:t>
             </a:r>
           </a:p>
         </p:txBody>
@@ -9623,7 +9623,7 @@
                 </a:solidFill>
                 <a:latin typeface="Calibri"/>
               </a:rPr>
-              <a:t>At 2,000 steps the INT8 tier gained nothing. We first concluded that QAT only helps severe damage. At 12,000 steps it removed 61 percent. The first result was a step-budget effect.</a:t>
+              <a:t>At 2,000 steps the INT8 tier gained nothing. The first conclusion was that QAT only helps severe damage. At 12,000 steps it removed 61 percent. The first result was a step-budget effect.</a:t>
             </a:r>
           </a:p>
           <a:p>
@@ -9639,7 +9639,7 @@
                 </a:solidFill>
                 <a:latin typeface="Calibri"/>
               </a:rPr>
-              <a:t>This is our most useful finding, not a failure: the repair is as large as the damage that the choice left behind.</a:t>
+              <a:t>This is the most useful finding, not a failure: the repair is as large as the damage that the choice left behind.</a:t>
             </a:r>
           </a:p>
         </p:txBody>
@@ -9735,7 +9735,7 @@
                 </a:solidFill>
                 <a:latin typeface="Cambria"/>
               </a:rPr>
-              <a:t>We did not get a speedup. Here is why.</a:t>
+              <a:t>No speedup. Here is why.</a:t>
             </a:r>
           </a:p>
         </p:txBody>
@@ -10050,7 +10050,7 @@
                 </a:solidFill>
                 <a:latin typeface="Calibri"/>
               </a:rPr>
-              <a:t>We make no speed claim for FP8, INT4 or FP4. These formats run as simulated quantization.</a:t>
+              <a:t>No speed claim is made for FP8, INT4 or FP4. These formats run as simulated quantization.</a:t>
             </a:r>
           </a:p>
           <a:p>

</xml_diff>